<commit_message>
fix: remove confusing slide template, add alt text to placeholders
</commit_message>
<xml_diff>
--- a/templates/Mattoni.pptx
+++ b/templates/Mattoni.pptx
@@ -5,24 +5,23 @@
     <p:sldMasterId id="2147483660" r:id="rId1"/>
   </p:sldMasterIdLst>
   <p:notesMasterIdLst>
-    <p:notesMasterId r:id="rId7"/>
+    <p:notesMasterId r:id="rId6"/>
   </p:notesMasterIdLst>
   <p:sldIdLst>
     <p:sldId id="280" r:id="rId2"/>
     <p:sldId id="281" r:id="rId3"/>
     <p:sldId id="282" r:id="rId4"/>
-    <p:sldId id="283" r:id="rId5"/>
-    <p:sldId id="284" r:id="rId6"/>
+    <p:sldId id="284" r:id="rId5"/>
   </p:sldIdLst>
   <p:sldSz cx="12192000" cy="6858000"/>
   <p:notesSz cx="6858000" cy="9144000"/>
   <p:embeddedFontLst>
     <p:embeddedFont>
       <p:font typeface="Century Gothic" panose="020B0502020202020204" pitchFamily="34" charset="0"/>
-      <p:regular r:id="rId8"/>
-      <p:bold r:id="rId9"/>
-      <p:italic r:id="rId10"/>
-      <p:boldItalic r:id="rId11"/>
+      <p:regular r:id="rId7"/>
+      <p:bold r:id="rId8"/>
+      <p:italic r:id="rId9"/>
+      <p:boldItalic r:id="rId10"/>
     </p:embeddedFont>
   </p:embeddedFontLst>
   <p:defaultTextStyle>
@@ -126,6 +125,14 @@
     </p:ext>
   </p:extLst>
 </p:presentation>
+</file>
+
+<file path=ppt/revisionInfo.xml><?xml version="1.0" encoding="utf-8"?>
+<p1510:revInfo xmlns:a="http://schemas.openxmlformats.org/drawingml/2006/main" xmlns:r="http://schemas.openxmlformats.org/officeDocument/2006/relationships" xmlns:p1510="http://schemas.microsoft.com/office/powerpoint/2015/10/main">
+  <p1510:revLst>
+    <p1510:client id="{DADF522B-198B-48F5-BBCD-7A07B8123C55}" v="38" dt="2026-03-05T08:02:28.535"/>
+  </p1510:revLst>
+</p1510:revInfo>
 </file>
 
 <file path=ppt/changesInfos/changesInfo1.xml><?xml version="1.0" encoding="utf-8"?>
@@ -251,6 +258,83 @@
       </pc:sldChg>
     </pc:docChg>
   </pc:docChgLst>
+  <pc:docChgLst>
+    <pc:chgData name="Janeček Vojtěch" userId="359a94ea-d6cb-422c-843d-68a5699d93df" providerId="ADAL" clId="{AE4D7728-6585-4387-958F-0752C1A8957C}"/>
+    <pc:docChg chg="delSld modSld">
+      <pc:chgData name="Janeček Vojtěch" userId="359a94ea-d6cb-422c-843d-68a5699d93df" providerId="ADAL" clId="{AE4D7728-6585-4387-958F-0752C1A8957C}" dt="2026-03-05T08:02:28.535" v="164" actId="962"/>
+      <pc:docMkLst>
+        <pc:docMk/>
+      </pc:docMkLst>
+      <pc:sldChg chg="modSp mod">
+        <pc:chgData name="Janeček Vojtěch" userId="359a94ea-d6cb-422c-843d-68a5699d93df" providerId="ADAL" clId="{AE4D7728-6585-4387-958F-0752C1A8957C}" dt="2026-03-05T08:02:28.535" v="164" actId="962"/>
+        <pc:sldMkLst>
+          <pc:docMk/>
+          <pc:sldMk cId="2081708087" sldId="281"/>
+        </pc:sldMkLst>
+        <pc:spChg chg="mod">
+          <ac:chgData name="Janeček Vojtěch" userId="359a94ea-d6cb-422c-843d-68a5699d93df" providerId="ADAL" clId="{AE4D7728-6585-4387-958F-0752C1A8957C}" dt="2026-03-05T08:02:23.457" v="148" actId="962"/>
+          <ac:spMkLst>
+            <pc:docMk/>
+            <pc:sldMk cId="2081708087" sldId="281"/>
+            <ac:spMk id="2" creationId="{FF126EC5-1098-B18A-4789-83E1E6A53CA6}"/>
+          </ac:spMkLst>
+        </pc:spChg>
+        <pc:spChg chg="mod">
+          <ac:chgData name="Janeček Vojtěch" userId="359a94ea-d6cb-422c-843d-68a5699d93df" providerId="ADAL" clId="{AE4D7728-6585-4387-958F-0752C1A8957C}" dt="2026-03-05T08:02:28.535" v="164" actId="962"/>
+          <ac:spMkLst>
+            <pc:docMk/>
+            <pc:sldMk cId="2081708087" sldId="281"/>
+            <ac:spMk id="3" creationId="{F96F76FB-09C6-FDB0-9C26-8740582B1869}"/>
+          </ac:spMkLst>
+        </pc:spChg>
+      </pc:sldChg>
+      <pc:sldChg chg="modSp mod">
+        <pc:chgData name="Janeček Vojtěch" userId="359a94ea-d6cb-422c-843d-68a5699d93df" providerId="ADAL" clId="{AE4D7728-6585-4387-958F-0752C1A8957C}" dt="2026-03-05T08:02:14.376" v="106" actId="962"/>
+        <pc:sldMkLst>
+          <pc:docMk/>
+          <pc:sldMk cId="3483782497" sldId="282"/>
+        </pc:sldMkLst>
+        <pc:spChg chg="mod">
+          <ac:chgData name="Janeček Vojtěch" userId="359a94ea-d6cb-422c-843d-68a5699d93df" providerId="ADAL" clId="{AE4D7728-6585-4387-958F-0752C1A8957C}" dt="2026-03-05T08:01:58.691" v="50" actId="962"/>
+          <ac:spMkLst>
+            <pc:docMk/>
+            <pc:sldMk cId="3483782497" sldId="282"/>
+            <ac:spMk id="2" creationId="{FE0B90AD-33B8-C59E-362D-8F7F2B85F064}"/>
+          </ac:spMkLst>
+        </pc:spChg>
+        <pc:spChg chg="mod">
+          <ac:chgData name="Janeček Vojtěch" userId="359a94ea-d6cb-422c-843d-68a5699d93df" providerId="ADAL" clId="{AE4D7728-6585-4387-958F-0752C1A8957C}" dt="2026-03-05T08:02:14.376" v="106" actId="962"/>
+          <ac:spMkLst>
+            <pc:docMk/>
+            <pc:sldMk cId="3483782497" sldId="282"/>
+            <ac:spMk id="3" creationId="{CF01B201-37F2-DF00-C9DC-304324380AD8}"/>
+          </ac:spMkLst>
+        </pc:spChg>
+      </pc:sldChg>
+      <pc:sldChg chg="del">
+        <pc:chgData name="Janeček Vojtěch" userId="359a94ea-d6cb-422c-843d-68a5699d93df" providerId="ADAL" clId="{AE4D7728-6585-4387-958F-0752C1A8957C}" dt="2026-03-05T08:00:52.291" v="0" actId="47"/>
+        <pc:sldMkLst>
+          <pc:docMk/>
+          <pc:sldMk cId="1704810340" sldId="283"/>
+        </pc:sldMkLst>
+      </pc:sldChg>
+      <pc:sldChg chg="modSp mod">
+        <pc:chgData name="Janeček Vojtěch" userId="359a94ea-d6cb-422c-843d-68a5699d93df" providerId="ADAL" clId="{AE4D7728-6585-4387-958F-0752C1A8957C}" dt="2026-03-05T08:01:29.516" v="28" actId="962"/>
+        <pc:sldMkLst>
+          <pc:docMk/>
+          <pc:sldMk cId="1677441268" sldId="284"/>
+        </pc:sldMkLst>
+        <pc:spChg chg="mod">
+          <ac:chgData name="Janeček Vojtěch" userId="359a94ea-d6cb-422c-843d-68a5699d93df" providerId="ADAL" clId="{AE4D7728-6585-4387-958F-0752C1A8957C}" dt="2026-03-05T08:01:29.516" v="28" actId="962"/>
+          <ac:spMkLst>
+            <pc:docMk/>
+            <pc:sldMk cId="1677441268" sldId="284"/>
+            <ac:spMk id="2" creationId="{F285850C-4AE8-3550-6961-74FF61A31EBB}"/>
+          </ac:spMkLst>
+        </pc:spChg>
+      </pc:sldChg>
+    </pc:docChg>
+  </pc:docChgLst>
 </pc:chgInfo>
 </file>
 
@@ -336,7 +420,7 @@
           <a:p>
             <a:fld id="{37945605-543E-45F1-86CB-E208619F97AB}" type="datetimeFigureOut">
               <a:rPr lang="cs-CZ" smtClean="0"/>
-              <a:t>23.02.2026</a:t>
+              <a:t>05.03.2026</a:t>
             </a:fld>
             <a:endParaRPr lang="cs-CZ"/>
           </a:p>
@@ -4143,7 +4227,7 @@
       </p:grpSpPr>
       <p:sp>
         <p:nvSpPr>
-          <p:cNvPr id="2" name="Nadpis 1">
+          <p:cNvPr id="2" name="Nadpis 1" descr="Title of presentation">
             <a:extLst>
               <a:ext uri="{FF2B5EF4-FFF2-40B4-BE49-F238E27FC236}">
                 <a16:creationId xmlns:a16="http://schemas.microsoft.com/office/drawing/2014/main" id="{FF126EC5-1098-B18A-4789-83E1E6A53CA6}"/>
@@ -4162,13 +4246,13 @@
           <a:bodyPr/>
           <a:lstStyle/>
           <a:p>
-            <a:endParaRPr lang="cs-CZ"/>
+            <a:endParaRPr lang="cs-CZ" dirty="0"/>
           </a:p>
         </p:txBody>
       </p:sp>
       <p:sp>
         <p:nvSpPr>
-          <p:cNvPr id="3" name="Zástupný text 2">
+          <p:cNvPr id="3" name="Zástupný text 2" descr="Date">
             <a:extLst>
               <a:ext uri="{FF2B5EF4-FFF2-40B4-BE49-F238E27FC236}">
                 <a16:creationId xmlns:a16="http://schemas.microsoft.com/office/drawing/2014/main" id="{F96F76FB-09C6-FDB0-9C26-8740582B1869}"/>
@@ -4187,7 +4271,7 @@
           <a:bodyPr/>
           <a:lstStyle/>
           <a:p>
-            <a:endParaRPr lang="cs-CZ"/>
+            <a:endParaRPr lang="cs-CZ" dirty="0"/>
           </a:p>
         </p:txBody>
       </p:sp>
@@ -4223,7 +4307,7 @@
       </p:grpSpPr>
       <p:sp>
         <p:nvSpPr>
-          <p:cNvPr id="2" name="Zástupný obsah 1">
+          <p:cNvPr id="2" name="Zástupný obsah 1" descr="context box">
             <a:extLst>
               <a:ext uri="{FF2B5EF4-FFF2-40B4-BE49-F238E27FC236}">
                 <a16:creationId xmlns:a16="http://schemas.microsoft.com/office/drawing/2014/main" id="{FE0B90AD-33B8-C59E-362D-8F7F2B85F064}"/>
@@ -4242,13 +4326,13 @@
           <a:bodyPr/>
           <a:lstStyle/>
           <a:p>
-            <a:endParaRPr lang="cs-CZ"/>
+            <a:endParaRPr lang="cs-CZ" dirty="0"/>
           </a:p>
         </p:txBody>
       </p:sp>
       <p:sp>
         <p:nvSpPr>
-          <p:cNvPr id="3" name="Nadpis 2">
+          <p:cNvPr id="3" name="Nadpis 2" descr="Title of context slide">
             <a:extLst>
               <a:ext uri="{FF2B5EF4-FFF2-40B4-BE49-F238E27FC236}">
                 <a16:creationId xmlns:a16="http://schemas.microsoft.com/office/drawing/2014/main" id="{CF01B201-37F2-DF00-C9DC-304324380AD8}"/>
@@ -4303,162 +4387,7 @@
       </p:grpSpPr>
       <p:sp>
         <p:nvSpPr>
-          <p:cNvPr id="2" name="Zástupný text 1">
-            <a:extLst>
-              <a:ext uri="{FF2B5EF4-FFF2-40B4-BE49-F238E27FC236}">
-                <a16:creationId xmlns:a16="http://schemas.microsoft.com/office/drawing/2014/main" id="{09C4DC60-2A31-FFF7-0FE0-5F4BE9927E27}"/>
-              </a:ext>
-            </a:extLst>
-          </p:cNvPr>
-          <p:cNvSpPr>
-            <a:spLocks noGrp="1"/>
-          </p:cNvSpPr>
-          <p:nvPr>
-            <p:ph type="body" idx="1"/>
-          </p:nvPr>
-        </p:nvSpPr>
-        <p:spPr/>
-        <p:txBody>
-          <a:bodyPr/>
-          <a:lstStyle/>
-          <a:p>
-            <a:endParaRPr lang="cs-CZ"/>
-          </a:p>
-        </p:txBody>
-      </p:sp>
-      <p:sp>
-        <p:nvSpPr>
-          <p:cNvPr id="3" name="Zástupný obsah 2">
-            <a:extLst>
-              <a:ext uri="{FF2B5EF4-FFF2-40B4-BE49-F238E27FC236}">
-                <a16:creationId xmlns:a16="http://schemas.microsoft.com/office/drawing/2014/main" id="{D9D93AAB-7EC8-0FEB-9328-A96E305A92BB}"/>
-              </a:ext>
-            </a:extLst>
-          </p:cNvPr>
-          <p:cNvSpPr>
-            <a:spLocks noGrp="1"/>
-          </p:cNvSpPr>
-          <p:nvPr>
-            <p:ph sz="half" idx="2"/>
-          </p:nvPr>
-        </p:nvSpPr>
-        <p:spPr/>
-        <p:txBody>
-          <a:bodyPr/>
-          <a:lstStyle/>
-          <a:p>
-            <a:endParaRPr lang="cs-CZ"/>
-          </a:p>
-        </p:txBody>
-      </p:sp>
-      <p:sp>
-        <p:nvSpPr>
-          <p:cNvPr id="4" name="Zástupný text 3">
-            <a:extLst>
-              <a:ext uri="{FF2B5EF4-FFF2-40B4-BE49-F238E27FC236}">
-                <a16:creationId xmlns:a16="http://schemas.microsoft.com/office/drawing/2014/main" id="{BEDFE94D-73D2-6E66-914B-48353B18FFC1}"/>
-              </a:ext>
-            </a:extLst>
-          </p:cNvPr>
-          <p:cNvSpPr>
-            <a:spLocks noGrp="1"/>
-          </p:cNvSpPr>
-          <p:nvPr>
-            <p:ph type="body" sz="quarter" idx="3"/>
-          </p:nvPr>
-        </p:nvSpPr>
-        <p:spPr/>
-        <p:txBody>
-          <a:bodyPr/>
-          <a:lstStyle/>
-          <a:p>
-            <a:endParaRPr lang="cs-CZ"/>
-          </a:p>
-        </p:txBody>
-      </p:sp>
-      <p:sp>
-        <p:nvSpPr>
-          <p:cNvPr id="5" name="Zástupný obsah 4">
-            <a:extLst>
-              <a:ext uri="{FF2B5EF4-FFF2-40B4-BE49-F238E27FC236}">
-                <a16:creationId xmlns:a16="http://schemas.microsoft.com/office/drawing/2014/main" id="{51624D6A-767E-5369-2C1C-ADC498222153}"/>
-              </a:ext>
-            </a:extLst>
-          </p:cNvPr>
-          <p:cNvSpPr>
-            <a:spLocks noGrp="1"/>
-          </p:cNvSpPr>
-          <p:nvPr>
-            <p:ph sz="quarter" idx="4"/>
-          </p:nvPr>
-        </p:nvSpPr>
-        <p:spPr/>
-        <p:txBody>
-          <a:bodyPr/>
-          <a:lstStyle/>
-          <a:p>
-            <a:endParaRPr lang="cs-CZ"/>
-          </a:p>
-        </p:txBody>
-      </p:sp>
-      <p:sp>
-        <p:nvSpPr>
-          <p:cNvPr id="6" name="Nadpis 5">
-            <a:extLst>
-              <a:ext uri="{FF2B5EF4-FFF2-40B4-BE49-F238E27FC236}">
-                <a16:creationId xmlns:a16="http://schemas.microsoft.com/office/drawing/2014/main" id="{86BA5E3F-FF04-665A-0D2B-3C13F59A1430}"/>
-              </a:ext>
-            </a:extLst>
-          </p:cNvPr>
-          <p:cNvSpPr>
-            <a:spLocks noGrp="1"/>
-          </p:cNvSpPr>
-          <p:nvPr>
-            <p:ph type="title"/>
-          </p:nvPr>
-        </p:nvSpPr>
-        <p:spPr/>
-        <p:txBody>
-          <a:bodyPr/>
-          <a:lstStyle/>
-          <a:p>
-            <a:endParaRPr lang="cs-CZ"/>
-          </a:p>
-        </p:txBody>
-      </p:sp>
-    </p:spTree>
-    <p:extLst>
-      <p:ext uri="{BB962C8B-B14F-4D97-AF65-F5344CB8AC3E}">
-        <p14:creationId xmlns:p14="http://schemas.microsoft.com/office/powerpoint/2010/main" val="1704810340"/>
-      </p:ext>
-    </p:extLst>
-  </p:cSld>
-  <p:clrMapOvr>
-    <a:masterClrMapping/>
-  </p:clrMapOvr>
-</p:sld>
-</file>
-
-<file path=ppt/slides/slide5.xml><?xml version="1.0" encoding="utf-8"?>
-<p:sld xmlns:a="http://schemas.openxmlformats.org/drawingml/2006/main" xmlns:r="http://schemas.openxmlformats.org/officeDocument/2006/relationships" xmlns:p="http://schemas.openxmlformats.org/presentationml/2006/main">
-  <p:cSld>
-    <p:spTree>
-      <p:nvGrpSpPr>
-        <p:cNvPr id="1" name=""/>
-        <p:cNvGrpSpPr/>
-        <p:nvPr/>
-      </p:nvGrpSpPr>
-      <p:grpSpPr>
-        <a:xfrm>
-          <a:off x="0" y="0"/>
-          <a:ext cx="0" cy="0"/>
-          <a:chOff x="0" y="0"/>
-          <a:chExt cx="0" cy="0"/>
-        </a:xfrm>
-      </p:grpSpPr>
-      <p:sp>
-        <p:nvSpPr>
-          <p:cNvPr id="2" name="Nadpis 1">
+          <p:cNvPr id="2" name="Nadpis 1" descr="Thank you">
             <a:extLst>
               <a:ext uri="{FF2B5EF4-FFF2-40B4-BE49-F238E27FC236}">
                 <a16:creationId xmlns:a16="http://schemas.microsoft.com/office/drawing/2014/main" id="{F285850C-4AE8-3550-6961-74FF61A31EBB}"/>
@@ -4482,7 +4411,7 @@
           <a:bodyPr/>
           <a:lstStyle/>
           <a:p>
-            <a:endParaRPr lang="cs-CZ"/>
+            <a:endParaRPr lang="cs-CZ" dirty="0"/>
           </a:p>
         </p:txBody>
       </p:sp>

</xml_diff>

<commit_message>
fix: remove all slides from template
</commit_message>
<xml_diff>
--- a/templates/Mattoni.pptx
+++ b/templates/Mattoni.pptx
@@ -5,23 +5,17 @@
     <p:sldMasterId id="2147483660" r:id="rId1"/>
   </p:sldMasterIdLst>
   <p:notesMasterIdLst>
-    <p:notesMasterId r:id="rId6"/>
+    <p:notesMasterId r:id="rId2"/>
   </p:notesMasterIdLst>
-  <p:sldIdLst>
-    <p:sldId id="280" r:id="rId2"/>
-    <p:sldId id="281" r:id="rId3"/>
-    <p:sldId id="282" r:id="rId4"/>
-    <p:sldId id="284" r:id="rId5"/>
-  </p:sldIdLst>
   <p:sldSz cx="12192000" cy="6858000"/>
   <p:notesSz cx="6858000" cy="9144000"/>
   <p:embeddedFontLst>
     <p:embeddedFont>
       <p:font typeface="Century Gothic" panose="020B0502020202020204" pitchFamily="34" charset="0"/>
-      <p:regular r:id="rId7"/>
-      <p:bold r:id="rId8"/>
-      <p:italic r:id="rId9"/>
-      <p:boldItalic r:id="rId10"/>
+      <p:regular r:id="rId3"/>
+      <p:bold r:id="rId4"/>
+      <p:italic r:id="rId5"/>
+      <p:boldItalic r:id="rId6"/>
     </p:embeddedFont>
   </p:embeddedFontLst>
   <p:defaultTextStyle>
@@ -260,13 +254,27 @@
   </pc:docChgLst>
   <pc:docChgLst>
     <pc:chgData name="Janeček Vojtěch" userId="359a94ea-d6cb-422c-843d-68a5699d93df" providerId="ADAL" clId="{AE4D7728-6585-4387-958F-0752C1A8957C}"/>
-    <pc:docChg chg="delSld modSld">
-      <pc:chgData name="Janeček Vojtěch" userId="359a94ea-d6cb-422c-843d-68a5699d93df" providerId="ADAL" clId="{AE4D7728-6585-4387-958F-0752C1A8957C}" dt="2026-03-05T08:02:28.535" v="164" actId="962"/>
+    <pc:docChg chg="addSld delSld modSld">
+      <pc:chgData name="Janeček Vojtěch" userId="359a94ea-d6cb-422c-843d-68a5699d93df" providerId="ADAL" clId="{AE4D7728-6585-4387-958F-0752C1A8957C}" dt="2026-03-05T08:54:01.877" v="170" actId="47"/>
       <pc:docMkLst>
         <pc:docMk/>
       </pc:docMkLst>
-      <pc:sldChg chg="modSp mod">
-        <pc:chgData name="Janeček Vojtěch" userId="359a94ea-d6cb-422c-843d-68a5699d93df" providerId="ADAL" clId="{AE4D7728-6585-4387-958F-0752C1A8957C}" dt="2026-03-05T08:02:28.535" v="164" actId="962"/>
+      <pc:sldChg chg="new del">
+        <pc:chgData name="Janeček Vojtěch" userId="359a94ea-d6cb-422c-843d-68a5699d93df" providerId="ADAL" clId="{AE4D7728-6585-4387-958F-0752C1A8957C}" dt="2026-03-05T08:54:01.877" v="170" actId="47"/>
+        <pc:sldMkLst>
+          <pc:docMk/>
+          <pc:sldMk cId="2702477761" sldId="256"/>
+        </pc:sldMkLst>
+      </pc:sldChg>
+      <pc:sldChg chg="del">
+        <pc:chgData name="Janeček Vojtěch" userId="359a94ea-d6cb-422c-843d-68a5699d93df" providerId="ADAL" clId="{AE4D7728-6585-4387-958F-0752C1A8957C}" dt="2026-03-05T08:53:57.075" v="168" actId="47"/>
+        <pc:sldMkLst>
+          <pc:docMk/>
+          <pc:sldMk cId="1998932342" sldId="280"/>
+        </pc:sldMkLst>
+      </pc:sldChg>
+      <pc:sldChg chg="modSp del mod">
+        <pc:chgData name="Janeček Vojtěch" userId="359a94ea-d6cb-422c-843d-68a5699d93df" providerId="ADAL" clId="{AE4D7728-6585-4387-958F-0752C1A8957C}" dt="2026-03-05T08:53:55.456" v="167" actId="47"/>
         <pc:sldMkLst>
           <pc:docMk/>
           <pc:sldMk cId="2081708087" sldId="281"/>
@@ -288,8 +296,8 @@
           </ac:spMkLst>
         </pc:spChg>
       </pc:sldChg>
-      <pc:sldChg chg="modSp mod">
-        <pc:chgData name="Janeček Vojtěch" userId="359a94ea-d6cb-422c-843d-68a5699d93df" providerId="ADAL" clId="{AE4D7728-6585-4387-958F-0752C1A8957C}" dt="2026-03-05T08:02:14.376" v="106" actId="962"/>
+      <pc:sldChg chg="modSp del mod">
+        <pc:chgData name="Janeček Vojtěch" userId="359a94ea-d6cb-422c-843d-68a5699d93df" providerId="ADAL" clId="{AE4D7728-6585-4387-958F-0752C1A8957C}" dt="2026-03-05T08:53:54.092" v="166" actId="47"/>
         <pc:sldMkLst>
           <pc:docMk/>
           <pc:sldMk cId="3483782497" sldId="282"/>
@@ -318,8 +326,8 @@
           <pc:sldMk cId="1704810340" sldId="283"/>
         </pc:sldMkLst>
       </pc:sldChg>
-      <pc:sldChg chg="modSp mod">
-        <pc:chgData name="Janeček Vojtěch" userId="359a94ea-d6cb-422c-843d-68a5699d93df" providerId="ADAL" clId="{AE4D7728-6585-4387-958F-0752C1A8957C}" dt="2026-03-05T08:01:29.516" v="28" actId="962"/>
+      <pc:sldChg chg="modSp del mod">
+        <pc:chgData name="Janeček Vojtěch" userId="359a94ea-d6cb-422c-843d-68a5699d93df" providerId="ADAL" clId="{AE4D7728-6585-4387-958F-0752C1A8957C}" dt="2026-03-05T08:53:52.602" v="165" actId="47"/>
         <pc:sldMkLst>
           <pc:docMk/>
           <pc:sldMk cId="1677441268" sldId="284"/>
@@ -4176,256 +4184,6 @@
     </p:otherStyle>
   </p:txStyles>
 </p:sldMaster>
-</file>
-
-<file path=ppt/slides/slide1.xml><?xml version="1.0" encoding="utf-8"?>
-<p:sld xmlns:a="http://schemas.openxmlformats.org/drawingml/2006/main" xmlns:r="http://schemas.openxmlformats.org/officeDocument/2006/relationships" xmlns:p="http://schemas.openxmlformats.org/presentationml/2006/main">
-  <p:cSld>
-    <p:spTree>
-      <p:nvGrpSpPr>
-        <p:cNvPr id="1" name=""/>
-        <p:cNvGrpSpPr/>
-        <p:nvPr/>
-      </p:nvGrpSpPr>
-      <p:grpSpPr>
-        <a:xfrm>
-          <a:off x="0" y="0"/>
-          <a:ext cx="0" cy="0"/>
-          <a:chOff x="0" y="0"/>
-          <a:chExt cx="0" cy="0"/>
-        </a:xfrm>
-      </p:grpSpPr>
-    </p:spTree>
-    <p:extLst>
-      <p:ext uri="{BB962C8B-B14F-4D97-AF65-F5344CB8AC3E}">
-        <p14:creationId xmlns:p14="http://schemas.microsoft.com/office/powerpoint/2010/main" val="1998932342"/>
-      </p:ext>
-    </p:extLst>
-  </p:cSld>
-  <p:clrMapOvr>
-    <a:masterClrMapping/>
-  </p:clrMapOvr>
-</p:sld>
-</file>
-
-<file path=ppt/slides/slide2.xml><?xml version="1.0" encoding="utf-8"?>
-<p:sld xmlns:a="http://schemas.openxmlformats.org/drawingml/2006/main" xmlns:r="http://schemas.openxmlformats.org/officeDocument/2006/relationships" xmlns:p="http://schemas.openxmlformats.org/presentationml/2006/main">
-  <p:cSld>
-    <p:spTree>
-      <p:nvGrpSpPr>
-        <p:cNvPr id="1" name=""/>
-        <p:cNvGrpSpPr/>
-        <p:nvPr/>
-      </p:nvGrpSpPr>
-      <p:grpSpPr>
-        <a:xfrm>
-          <a:off x="0" y="0"/>
-          <a:ext cx="0" cy="0"/>
-          <a:chOff x="0" y="0"/>
-          <a:chExt cx="0" cy="0"/>
-        </a:xfrm>
-      </p:grpSpPr>
-      <p:sp>
-        <p:nvSpPr>
-          <p:cNvPr id="2" name="Nadpis 1" descr="Title of presentation">
-            <a:extLst>
-              <a:ext uri="{FF2B5EF4-FFF2-40B4-BE49-F238E27FC236}">
-                <a16:creationId xmlns:a16="http://schemas.microsoft.com/office/drawing/2014/main" id="{FF126EC5-1098-B18A-4789-83E1E6A53CA6}"/>
-              </a:ext>
-            </a:extLst>
-          </p:cNvPr>
-          <p:cNvSpPr>
-            <a:spLocks noGrp="1"/>
-          </p:cNvSpPr>
-          <p:nvPr>
-            <p:ph type="title"/>
-          </p:nvPr>
-        </p:nvSpPr>
-        <p:spPr/>
-        <p:txBody>
-          <a:bodyPr/>
-          <a:lstStyle/>
-          <a:p>
-            <a:endParaRPr lang="cs-CZ" dirty="0"/>
-          </a:p>
-        </p:txBody>
-      </p:sp>
-      <p:sp>
-        <p:nvSpPr>
-          <p:cNvPr id="3" name="Zástupný text 2" descr="Date">
-            <a:extLst>
-              <a:ext uri="{FF2B5EF4-FFF2-40B4-BE49-F238E27FC236}">
-                <a16:creationId xmlns:a16="http://schemas.microsoft.com/office/drawing/2014/main" id="{F96F76FB-09C6-FDB0-9C26-8740582B1869}"/>
-              </a:ext>
-            </a:extLst>
-          </p:cNvPr>
-          <p:cNvSpPr>
-            <a:spLocks noGrp="1"/>
-          </p:cNvSpPr>
-          <p:nvPr>
-            <p:ph type="body" idx="1"/>
-          </p:nvPr>
-        </p:nvSpPr>
-        <p:spPr/>
-        <p:txBody>
-          <a:bodyPr/>
-          <a:lstStyle/>
-          <a:p>
-            <a:endParaRPr lang="cs-CZ" dirty="0"/>
-          </a:p>
-        </p:txBody>
-      </p:sp>
-    </p:spTree>
-    <p:extLst>
-      <p:ext uri="{BB962C8B-B14F-4D97-AF65-F5344CB8AC3E}">
-        <p14:creationId xmlns:p14="http://schemas.microsoft.com/office/powerpoint/2010/main" val="2081708087"/>
-      </p:ext>
-    </p:extLst>
-  </p:cSld>
-  <p:clrMapOvr>
-    <a:masterClrMapping/>
-  </p:clrMapOvr>
-</p:sld>
-</file>
-
-<file path=ppt/slides/slide3.xml><?xml version="1.0" encoding="utf-8"?>
-<p:sld xmlns:a="http://schemas.openxmlformats.org/drawingml/2006/main" xmlns:r="http://schemas.openxmlformats.org/officeDocument/2006/relationships" xmlns:p="http://schemas.openxmlformats.org/presentationml/2006/main">
-  <p:cSld>
-    <p:spTree>
-      <p:nvGrpSpPr>
-        <p:cNvPr id="1" name=""/>
-        <p:cNvGrpSpPr/>
-        <p:nvPr/>
-      </p:nvGrpSpPr>
-      <p:grpSpPr>
-        <a:xfrm>
-          <a:off x="0" y="0"/>
-          <a:ext cx="0" cy="0"/>
-          <a:chOff x="0" y="0"/>
-          <a:chExt cx="0" cy="0"/>
-        </a:xfrm>
-      </p:grpSpPr>
-      <p:sp>
-        <p:nvSpPr>
-          <p:cNvPr id="2" name="Zástupný obsah 1" descr="context box">
-            <a:extLst>
-              <a:ext uri="{FF2B5EF4-FFF2-40B4-BE49-F238E27FC236}">
-                <a16:creationId xmlns:a16="http://schemas.microsoft.com/office/drawing/2014/main" id="{FE0B90AD-33B8-C59E-362D-8F7F2B85F064}"/>
-              </a:ext>
-            </a:extLst>
-          </p:cNvPr>
-          <p:cNvSpPr>
-            <a:spLocks noGrp="1"/>
-          </p:cNvSpPr>
-          <p:nvPr>
-            <p:ph idx="1"/>
-          </p:nvPr>
-        </p:nvSpPr>
-        <p:spPr/>
-        <p:txBody>
-          <a:bodyPr/>
-          <a:lstStyle/>
-          <a:p>
-            <a:endParaRPr lang="cs-CZ" dirty="0"/>
-          </a:p>
-        </p:txBody>
-      </p:sp>
-      <p:sp>
-        <p:nvSpPr>
-          <p:cNvPr id="3" name="Nadpis 2" descr="Title of context slide">
-            <a:extLst>
-              <a:ext uri="{FF2B5EF4-FFF2-40B4-BE49-F238E27FC236}">
-                <a16:creationId xmlns:a16="http://schemas.microsoft.com/office/drawing/2014/main" id="{CF01B201-37F2-DF00-C9DC-304324380AD8}"/>
-              </a:ext>
-            </a:extLst>
-          </p:cNvPr>
-          <p:cNvSpPr>
-            <a:spLocks noGrp="1"/>
-          </p:cNvSpPr>
-          <p:nvPr>
-            <p:ph type="title"/>
-          </p:nvPr>
-        </p:nvSpPr>
-        <p:spPr/>
-        <p:txBody>
-          <a:bodyPr/>
-          <a:lstStyle/>
-          <a:p>
-            <a:endParaRPr lang="cs-CZ"/>
-          </a:p>
-        </p:txBody>
-      </p:sp>
-    </p:spTree>
-    <p:extLst>
-      <p:ext uri="{BB962C8B-B14F-4D97-AF65-F5344CB8AC3E}">
-        <p14:creationId xmlns:p14="http://schemas.microsoft.com/office/powerpoint/2010/main" val="3483782497"/>
-      </p:ext>
-    </p:extLst>
-  </p:cSld>
-  <p:clrMapOvr>
-    <a:masterClrMapping/>
-  </p:clrMapOvr>
-</p:sld>
-</file>
-
-<file path=ppt/slides/slide4.xml><?xml version="1.0" encoding="utf-8"?>
-<p:sld xmlns:a="http://schemas.openxmlformats.org/drawingml/2006/main" xmlns:r="http://schemas.openxmlformats.org/officeDocument/2006/relationships" xmlns:p="http://schemas.openxmlformats.org/presentationml/2006/main">
-  <p:cSld>
-    <p:spTree>
-      <p:nvGrpSpPr>
-        <p:cNvPr id="1" name=""/>
-        <p:cNvGrpSpPr/>
-        <p:nvPr/>
-      </p:nvGrpSpPr>
-      <p:grpSpPr>
-        <a:xfrm>
-          <a:off x="0" y="0"/>
-          <a:ext cx="0" cy="0"/>
-          <a:chOff x="0" y="0"/>
-          <a:chExt cx="0" cy="0"/>
-        </a:xfrm>
-      </p:grpSpPr>
-      <p:sp>
-        <p:nvSpPr>
-          <p:cNvPr id="2" name="Nadpis 1" descr="Thank you">
-            <a:extLst>
-              <a:ext uri="{FF2B5EF4-FFF2-40B4-BE49-F238E27FC236}">
-                <a16:creationId xmlns:a16="http://schemas.microsoft.com/office/drawing/2014/main" id="{F285850C-4AE8-3550-6961-74FF61A31EBB}"/>
-              </a:ext>
-            </a:extLst>
-          </p:cNvPr>
-          <p:cNvSpPr>
-            <a:spLocks noGrp="1"/>
-          </p:cNvSpPr>
-          <p:nvPr>
-            <p:ph type="title" idx="4294967295"/>
-          </p:nvPr>
-        </p:nvSpPr>
-        <p:spPr>
-          <a:xfrm>
-            <a:off x="971550" y="2616201"/>
-            <a:ext cx="10515600" cy="1325562"/>
-          </a:xfrm>
-        </p:spPr>
-        <p:txBody>
-          <a:bodyPr/>
-          <a:lstStyle/>
-          <a:p>
-            <a:endParaRPr lang="cs-CZ" dirty="0"/>
-          </a:p>
-        </p:txBody>
-      </p:sp>
-    </p:spTree>
-    <p:extLst>
-      <p:ext uri="{BB962C8B-B14F-4D97-AF65-F5344CB8AC3E}">
-        <p14:creationId xmlns:p14="http://schemas.microsoft.com/office/powerpoint/2010/main" val="1677441268"/>
-      </p:ext>
-    </p:extLst>
-  </p:cSld>
-  <p:clrMapOvr>
-    <a:masterClrMapping/>
-  </p:clrMapOvr>
-</p:sld>
 </file>
 
 <file path=ppt/tags/tag1.xml><?xml version="1.0" encoding="utf-8"?>

</xml_diff>